<commit_message>
docs(demo): document v0.3 delivery handoff and verified fixture demonstration
</commit_message>
<xml_diff>
--- a/docs/DEMO_SLIDES.pptx
+++ b/docs/DEMO_SLIDES.pptx
@@ -509,7 +509,7 @@
           <a:lstStyle/>
           <a:p>
             <a:r>
-              <a:t>我们解决多门店库存占资和协同处置的问题。今天展示合成数据上的真实接口交互，不把模拟测算说成客户收益，也不把规则工具说成真实大模型。</a:t>
+              <a:t>货不压钱关注连锁零售中的库存成本占用和预计采购支出。本轮交付是依照魏的 v0.3 唯一契约整理的前端、合成数据和测试。演示录像明确使用接口夹具，不把它称为真实模型或后端计算结果。</a:t>
             </a:r>
           </a:p>
         </p:txBody>
@@ -579,7 +579,7 @@
           <a:lstStyle/>
           <a:p>
             <a:r>
-              <a:t>五个入口不是五套后端。当前调用既有确定性接口，页面负责把输入、证据、结果和下一步连起来。</a:t>
+              <a:t>五个入口通过同一运行接口提交分析范围、参数和版本。前端不重复实现五套业务计算，也不会把参考预期作为页面结果。金额和约束由魏的工具层计算，模型负责理解、组织与解释。</a:t>
             </a:r>
           </a:p>
         </p:txBody>
@@ -649,7 +649,7 @@
           <a:lstStyle/>
           <a:p>
             <a:r>
-              <a:t>先将数量改成100观察约束错误，再用默认参数中的40重算。实际结果以当前后端为准。保存审批后生成的是草稿，不会直接向ERP发货。</a:t>
+              <a:t>现在可以独立启动前端、查看输入包。没有配置 v0.3 服务时，运行会明确报 API_NOT_CONFIGURED。浏览器测试只验证给定契约响应下的界面行为，真实后端上线后还要重新联调。</a:t>
             </a:r>
           </a:p>
         </p:txBody>
@@ -719,7 +719,7 @@
           <a:lstStyle/>
           <a:p>
             <a:r>
-              <a:t>这些指标边界不同。内部调拨改变库存位置，可能产生配送费；它本身不能证明现金释放。实际回款还需要外部证据。</a:t>
+              <a:t>以城西店每日坚果 PO-003 少采购六袋为输入例子。先核对后端返回的门店、商品、采购单、数量和周期。预览没有模拟结果金额；点击确认后才计算。之后的模拟确认只记录演示决策。</a:t>
             </a:r>
           </a:p>
         </p:txBody>
@@ -789,7 +789,7 @@
           <a:lstStyle/>
           <a:p>
             <a:r>
-              <a:t>现场用浏览器离线模式展示一次失败，然后恢复重试。错误状态不是用一组样例数字填平，成功提示必须来自接口成功响应。</a:t>
+              <a:t>这里不声称客户已经获得收益。三十天模拟如果不安排后续补货，基线和减量方案都可能断货。只展示减少采购金额会误导决策，所以必须连同库存资金曲线、缺货风险和计算时点解释。</a:t>
             </a:r>
           </a:p>
         </p:txBody>
@@ -859,7 +859,7 @@
           <a:lstStyle/>
           <a:p>
             <a:r>
-              <a:t>测试场景与实际页面共享接口约束。生成器用于回放和验证，不会静默改写正在演示的数据库。测试数字必须从本次运行产生。</a:t>
+              <a:t>失败演示可以检查页面是否保留上下文、是否阻止错误决策。开发代理不自动重试写入。真实模型超时和恢复需要在魏的服务接入后单独验收，不能用浏览器夹具的通过数量代替。</a:t>
             </a:r>
           </a:p>
         </p:txBody>
@@ -929,7 +929,7 @@
           <a:lstStyle/>
           <a:p>
             <a:r>
-              <a:t>我们尊重代码所有权。朱的工作是展示接口与组织交互，后端的缺口会记录并交接，不通过前端补金额或增加假状态来绕开。</a:t>
+              <a:t>朱交付前端、合成场景、测试和演示。启动前端只需要 Python 标准库，不启动旧数据库或业务后端。录像展示真实浏览器操作，但响应来自显式测试夹具，因此它只能证明前端交互。</a:t>
             </a:r>
           </a:p>
         </p:txBody>
@@ -999,7 +999,7 @@
           <a:lstStyle/>
           <a:p>
             <a:r>
-              <a:t>本次前端演示交付不等于整个八模块项目已完成。真实模型、生产权限事务和ERP连接仍然是后续集成工作。</a:t>
+              <a:t>库存资金的取值时点、到货与销售先后、到期日能否销售，以及箱规和后续补货尚需双方冻结。本次不替魏实现后端，也不从前端补算这些数字。联调通过后再发布真实服务演示与模型评测结果。</a:t>
             </a:r>
           </a:p>
         </p:txBody>
@@ -4047,7 +4047,7 @@
               </a:defRPr>
             </a:pPr>
             <a:r>
-              <a:t>INVENTORY CASH AGENT</a:t>
+              <a:t>HUO BU YA QIAN / CONTRACT v0.3</a:t>
             </a:r>
           </a:p>
         </p:txBody>
@@ -4086,7 +4086,7 @@
               </a:defRPr>
             </a:pPr>
             <a:r>
-              <a:t>让库存决策</a:t>
+              <a:t>货不压钱</a:t>
             </a:r>
           </a:p>
           <a:p>
@@ -4102,7 +4102,7 @@
               </a:defRPr>
             </a:pPr>
             <a:r>
-              <a:t>走到人工确认</a:t>
+              <a:t>让库存建议有据可查</a:t>
             </a:r>
           </a:p>
         </p:txBody>
@@ -4141,7 +4141,7 @@
               </a:defRPr>
             </a:pPr>
             <a:r>
-              <a:t>从门店反馈到执行草稿，一条可以核对的业务流程。</a:t>
+              <a:t>五个业务入口，一份零售通用契约，使用虚构零食数据演示。</a:t>
             </a:r>
           </a:p>
         </p:txBody>
@@ -4223,7 +4223,7 @@
               </a:defRPr>
             </a:pPr>
             <a:r>
-              <a:t>发现库存异常与资金占用</a:t>
+              <a:t>范围与参数形成统一请求</a:t>
             </a:r>
           </a:p>
         </p:txBody>
@@ -4305,7 +4305,7 @@
               </a:defRPr>
             </a:pPr>
             <a:r>
-              <a:t>以证据、计算和约束支持决策</a:t>
+              <a:t>结果、证据、告警由服务返回</a:t>
             </a:r>
           </a:p>
         </p:txBody>
@@ -4387,7 +4387,7 @@
               </a:defRPr>
             </a:pPr>
             <a:r>
-              <a:t>以版本、审批和回执保留责任边界</a:t>
+              <a:t>情景先确认，建议只记录模拟决策</a:t>
             </a:r>
           </a:p>
         </p:txBody>
@@ -4469,7 +4469,7 @@
               </a:defRPr>
             </a:pPr>
             <a:r>
-              <a:t>合成演示数据 · 当前为规则计算版本</a:t>
+              <a:t>当前为前端契约交付 · 真实 v0.3 后端与模型尚未联调</a:t>
             </a:r>
           </a:p>
         </p:txBody>
@@ -4573,7 +4573,7 @@
               </a:defRPr>
             </a:pPr>
             <a:r>
-              <a:t>01 / PRODUCT</a:t>
+              <a:t>01 / FIVE AGENTS</a:t>
             </a:r>
           </a:p>
         </p:txBody>
@@ -4612,7 +4612,7 @@
               </a:defRPr>
             </a:pPr>
             <a:r>
-              <a:t>五个入口</a:t>
+              <a:t>五个业务入口</a:t>
             </a:r>
           </a:p>
           <a:p>
@@ -4628,7 +4628,7 @@
               </a:defRPr>
             </a:pPr>
             <a:r>
-              <a:t>共用一条流程</a:t>
+              <a:t>共用事实与返回结构</a:t>
             </a:r>
           </a:p>
         </p:txBody>
@@ -4667,7 +4667,7 @@
               </a:defRPr>
             </a:pPr>
             <a:r>
-              <a:t>同一份事实、同一套后端计算、同一套人工审批。</a:t>
+              <a:t>门店、商品、库存、销量、采购、批次和经营规则保持通用模型。</a:t>
             </a:r>
           </a:p>
         </p:txBody>
@@ -4749,7 +4749,7 @@
               </a:defRPr>
             </a:pPr>
             <a:r>
-              <a:t>滞销诊断：事实、原因假设、证据与缺项</a:t>
+              <a:t>滞销诊断：低动销、高占款及证据</a:t>
             </a:r>
           </a:p>
         </p:txBody>
@@ -4831,7 +4831,7 @@
               </a:defRPr>
             </a:pPr>
             <a:r>
-              <a:t>跨店调拨：门店、数量、费用与安全库存</a:t>
+              <a:t>跨店调拨：两店库存、数量及约束</a:t>
             </a:r>
           </a:p>
         </p:txBody>
@@ -4913,7 +4913,7 @@
               </a:defRPr>
             </a:pPr>
             <a:r>
-              <a:t>近效期：正常销售、调拨、促销、退供</a:t>
+              <a:t>近效期：预测窗口、批次与成本风险</a:t>
             </a:r>
           </a:p>
         </p:txBody>
@@ -4995,7 +4995,7 @@
               </a:defRPr>
             </a:pPr>
             <a:r>
-              <a:t>采购刹车：库存、在途、未执行量与付款</a:t>
+              <a:t>采购刹车：可调整采购量及缺货风险</a:t>
             </a:r>
           </a:p>
         </p:txBody>
@@ -5077,7 +5077,7 @@
               </a:defRPr>
             </a:pPr>
             <a:r>
-              <a:t>现金模拟：候选组合、业务约束与目标缺口</a:t>
+              <a:t>资金周转模拟：基线、方案、假设与风险</a:t>
             </a:r>
           </a:p>
         </p:txBody>
@@ -5159,7 +5159,7 @@
               </a:defRPr>
             </a:pPr>
             <a:r>
-              <a:t>已有业务入口与规则工具；真实模型适配仍待接入</a:t>
+              <a:t>门店、SKU、供应商与交易数据均为合成；不对应真实连锁企业</a:t>
             </a:r>
           </a:p>
         </p:txBody>
@@ -5263,7 +5263,7 @@
               </a:defRPr>
             </a:pPr>
             <a:r>
-              <a:t>02 / WALKTHROUGH</a:t>
+              <a:t>02 / CONTRACT</a:t>
             </a:r>
           </a:p>
         </p:txBody>
@@ -5302,7 +5302,7 @@
               </a:defRPr>
             </a:pPr>
             <a:r>
-              <a:t>反馈 → 诊断 → 调拨</a:t>
+              <a:t>统一运行</a:t>
             </a:r>
           </a:p>
           <a:p>
@@ -5318,7 +5318,7 @@
               </a:defRPr>
             </a:pPr>
             <a:r>
-              <a:t>确认后生成执行草稿</a:t>
+              <a:t>统一呈现结果</a:t>
             </a:r>
           </a:p>
         </p:txBody>
@@ -5357,7 +5357,7 @@
               </a:defRPr>
             </a:pPr>
             <a:r>
-              <a:t>演示西湖文三店的合成库存案例。</a:t>
+              <a:t>POST /api/v1/agent-runs</a:t>
             </a:r>
           </a:p>
         </p:txBody>
@@ -5439,7 +5439,7 @@
               </a:defRPr>
             </a:pPr>
             <a:r>
-              <a:t>01  核对库存、销量与原因缺项</a:t>
+              <a:t>请求：request_id、scope、params、数据与规则版本</a:t>
             </a:r>
           </a:p>
         </p:txBody>
@@ -5521,7 +5521,7 @@
               </a:defRPr>
             </a:pPr>
             <a:r>
-              <a:t>02  留存反馈原文，人工检查返回草稿</a:t>
+              <a:t>响应：run_id、状态、步骤、证据和建议</a:t>
             </a:r>
           </a:p>
         </p:txBody>
@@ -5603,7 +5603,7 @@
               </a:defRPr>
             </a:pPr>
             <a:r>
-              <a:t>03  修改数量并请求后端重算</a:t>
+              <a:t>收到响应后才展示实际返回步骤</a:t>
             </a:r>
           </a:p>
         </p:txBody>
@@ -5685,7 +5685,7 @@
               </a:defRPr>
             </a:pPr>
             <a:r>
-              <a:t>04  保存方案、提交审批、负责人确认</a:t>
+              <a:t>空值保持未知，空结果保持空</a:t>
             </a:r>
           </a:p>
         </p:txBody>
@@ -5767,7 +5767,7 @@
               </a:defRPr>
             </a:pPr>
             <a:r>
-              <a:t>05  生成执行任务，后续回执另行记录</a:t>
+              <a:t>关联信息或结构不符时阻止使用结果</a:t>
             </a:r>
           </a:p>
         </p:txBody>
@@ -5849,7 +5849,7 @@
               </a:defRPr>
             </a:pPr>
             <a:r>
-              <a:t>输入改变需重算；任务创建不等于 ERP 已执行</a:t>
+              <a:t>现有 main 旧后端尚无统一路由；前端不会调用旧工作台伪装兼容</a:t>
             </a:r>
           </a:p>
         </p:txBody>
@@ -5953,7 +5953,7 @@
               </a:defRPr>
             </a:pPr>
             <a:r>
-              <a:t>03 / MEASUREMENT</a:t>
+              <a:t>03 / CONFIRMATION</a:t>
             </a:r>
           </a:p>
         </p:txBody>
@@ -5992,7 +5992,7 @@
               </a:defRPr>
             </a:pPr>
             <a:r>
-              <a:t>四种金额</a:t>
+              <a:t>先核对情景</a:t>
             </a:r>
           </a:p>
           <a:p>
@@ -6008,7 +6008,7 @@
               </a:defRPr>
             </a:pPr>
             <a:r>
-              <a:t>分别回答四个问题</a:t>
+              <a:t>再开始模拟</a:t>
             </a:r>
           </a:p>
         </p:txBody>
@@ -6047,7 +6047,7 @@
               </a:defRPr>
             </a:pPr>
             <a:r>
-              <a:t>页面不会把库存搬动或预计报损减少当成现金回款。</a:t>
+              <a:t>描述调整 → preview → 人工核对 → simulate → 模拟决策。</a:t>
             </a:r>
           </a:p>
         </p:txBody>
@@ -6129,7 +6129,7 @@
               </a:defRPr>
             </a:pPr>
             <a:r>
-              <a:t>库存成本：这些货占用了多少成本？</a:t>
+              <a:t>预览只有结构化调整与假设，items 为空</a:t>
             </a:r>
           </a:p>
         </p:txBody>
@@ -6211,7 +6211,7 @@
               </a:defRPr>
             </a:pPr>
             <a:r>
-              <a:t>预计避免报损：处置可能减少多少损失？</a:t>
+              <a:t>确认后复用 session_id 和 scenario_id</a:t>
             </a:r>
           </a:p>
         </p:txBody>
@@ -6293,7 +6293,7 @@
               </a:defRPr>
             </a:pPr>
             <a:r>
-              <a:t>模拟净现金改善：期限内有哪些可计算现金事件？</a:t>
+              <a:t>confirmed=true 只允许开始计算</a:t>
             </a:r>
           </a:p>
         </p:txBody>
@@ -6375,7 +6375,7 @@
               </a:defRPr>
             </a:pPr>
             <a:r>
-              <a:t>实际回款：是否已有财务或执行回执支持？</a:t>
+              <a:t>修改输入使旧情景与旧结果失效</a:t>
             </a:r>
           </a:p>
         </p:txBody>
@@ -6383,6 +6383,88 @@
       <p:sp>
         <p:nvSpPr>
           <p:cNvPr id="13" name="Rectangle 12"/>
+          <p:cNvSpPr/>
+          <p:nvPr/>
+        </p:nvSpPr>
+        <p:spPr>
+          <a:xfrm>
+            <a:off x="640080" y="4956048"/>
+            <a:ext cx="41148" cy="41148"/>
+          </a:xfrm>
+          <a:prstGeom prst="rect">
+            <a:avLst/>
+          </a:prstGeom>
+          <a:solidFill>
+            <a:srgbClr val="9AD7B7"/>
+          </a:solidFill>
+          <a:ln>
+            <a:noFill/>
+          </a:ln>
+        </p:spPr>
+        <p:style>
+          <a:lnRef idx="1">
+            <a:schemeClr val="accent1"/>
+          </a:lnRef>
+          <a:fillRef idx="3">
+            <a:schemeClr val="accent1"/>
+          </a:fillRef>
+          <a:effectRef idx="2">
+            <a:schemeClr val="accent1"/>
+          </a:effectRef>
+          <a:fontRef idx="minor">
+            <a:schemeClr val="lt1"/>
+          </a:fontRef>
+        </p:style>
+        <p:txBody>
+          <a:bodyPr rtlCol="0" anchor="ctr"/>
+          <a:lstStyle/>
+          <a:p>
+            <a:pPr algn="ctr"/>
+          </a:p>
+        </p:txBody>
+      </p:sp>
+      <p:sp>
+        <p:nvSpPr>
+          <p:cNvPr id="14" name="TextBox 13"/>
+          <p:cNvSpPr txBox="1"/>
+          <p:nvPr/>
+        </p:nvSpPr>
+        <p:spPr>
+          <a:xfrm>
+            <a:off x="822960" y="4837176"/>
+            <a:ext cx="10607040" cy="393192"/>
+          </a:xfrm>
+          <a:prstGeom prst="rect">
+            <a:avLst/>
+          </a:prstGeom>
+          <a:noFill/>
+        </p:spPr>
+        <p:txBody>
+          <a:bodyPr wrap="square" lIns="0" rIns="0" tIns="0" bIns="0">
+            <a:spAutoFit/>
+          </a:bodyPr>
+          <a:lstStyle/>
+          <a:p>
+            <a:pPr>
+              <a:spcAft>
+                <a:spcPts val="500"/>
+              </a:spcAft>
+              <a:defRPr sz="1800" b="0">
+                <a:solidFill>
+                  <a:srgbClr val="EEF3F6"/>
+                </a:solidFill>
+                <a:latin typeface="Microsoft YaHei"/>
+              </a:defRPr>
+            </a:pPr>
+            <a:r>
+              <a:t>建议确认需返回 recorded / simulation</a:t>
+            </a:r>
+          </a:p>
+        </p:txBody>
+      </p:sp>
+      <p:sp>
+        <p:nvSpPr>
+          <p:cNvPr id="15" name="Rectangle 14"/>
           <p:cNvSpPr/>
           <p:nvPr/>
         </p:nvSpPr>
@@ -6425,7 +6507,7 @@
       </p:sp>
       <p:sp>
         <p:nvSpPr>
-          <p:cNvPr id="14" name="TextBox 13"/>
+          <p:cNvPr id="16" name="TextBox 15"/>
           <p:cNvSpPr txBox="1"/>
           <p:nvPr/>
         </p:nvSpPr>
@@ -6457,14 +6539,14 @@
               </a:defRPr>
             </a:pPr>
             <a:r>
-              <a:t>未知保持未知；不相加生成虚构 ROI</a:t>
-            </a:r>
-          </a:p>
-        </p:txBody>
-      </p:sp>
-      <p:sp>
-        <p:nvSpPr>
-          <p:cNvPr id="15" name="TextBox 14"/>
+              <a:t>情景确认与建议确认均不修改真实库存、采购单或收银数据</a:t>
+            </a:r>
+          </a:p>
+        </p:txBody>
+      </p:sp>
+      <p:sp>
+        <p:nvSpPr>
+          <p:cNvPr id="17" name="TextBox 16"/>
           <p:cNvSpPr txBox="1"/>
           <p:nvPr/>
         </p:nvSpPr>
@@ -6561,7 +6643,7 @@
               </a:defRPr>
             </a:pPr>
             <a:r>
-              <a:t>04 / FAILURE STATES</a:t>
+              <a:t>04 / MONEY AND RISK</a:t>
             </a:r>
           </a:p>
         </p:txBody>
@@ -6600,7 +6682,7 @@
               </a:defRPr>
             </a:pPr>
             <a:r>
-              <a:t>失败要看得见</a:t>
+              <a:t>分清金额含义</a:t>
             </a:r>
           </a:p>
           <a:p>
@@ -6616,7 +6698,7 @@
               </a:defRPr>
             </a:pPr>
             <a:r>
-              <a:t>旧结果不能继续用</a:t>
+              <a:t>同时解释风险</a:t>
             </a:r>
           </a:p>
         </p:txBody>
@@ -6655,7 +6737,7 @@
               </a:defRPr>
             </a:pPr>
             <a:r>
-              <a:t>交互状态直接进入现有请求与单据生命周期。</a:t>
+              <a:t>传输采用整数分，页面只换算显示，不自行生成业务数字。</a:t>
             </a:r>
           </a:p>
         </p:txBody>
@@ -6737,7 +6819,7 @@
               </a:defRPr>
             </a:pPr>
             <a:r>
-              <a:t>API 失败：显示错误、保留输入、显式重试</a:t>
+              <a:t>库存成本占用不等于银行账户余额</a:t>
             </a:r>
           </a:p>
         </p:txBody>
@@ -6819,7 +6901,7 @@
               </a:defRPr>
             </a:pPr>
             <a:r>
-              <a:t>快速切换：旧响应不能覆盖最后选择</a:t>
+              <a:t>采购减量表示预计避免未来采购承诺</a:t>
             </a:r>
           </a:p>
         </p:txBody>
@@ -6901,7 +6983,7 @@
               </a:defRPr>
             </a:pPr>
             <a:r>
-              <a:t>修改输入：旧计算和可提交状态立即失效</a:t>
+              <a:t>内部调拨不直接降低全链路库存总额</a:t>
             </a:r>
           </a:p>
         </p:txBody>
@@ -6983,7 +7065,7 @@
               </a:defRPr>
             </a:pPr>
             <a:r>
-              <a:t>约束不通过：展示原因，阻止下一步</a:t>
+              <a:t>近效期金额是成本风险敞口估算</a:t>
             </a:r>
           </a:p>
         </p:txBody>
@@ -7065,7 +7147,7 @@
               </a:defRPr>
             </a:pPr>
             <a:r>
-              <a:t>模型未接入：明确规则模式，不伪造推理轨迹</a:t>
+              <a:t>没有后续补货时，两种采购方案都可能缺货</a:t>
             </a:r>
           </a:p>
         </p:txBody>
@@ -7147,7 +7229,7 @@
               </a:defRPr>
             </a:pPr>
             <a:r>
-              <a:t>前端交互保护不能替代服务端事务和权限控制</a:t>
+              <a:t>模拟必须展示基线、方案、时间口径、假设与缺货风险</a:t>
             </a:r>
           </a:p>
         </p:txBody>
@@ -7251,7 +7333,7 @@
               </a:defRPr>
             </a:pPr>
             <a:r>
-              <a:t>05 / REPRODUCIBILITY</a:t>
+              <a:t>05 / FAILURE STATES</a:t>
             </a:r>
           </a:p>
         </p:txBody>
@@ -7290,7 +7372,7 @@
               </a:defRPr>
             </a:pPr>
             <a:r>
-              <a:t>同一场景</a:t>
+              <a:t>错误可以核对</a:t>
             </a:r>
           </a:p>
           <a:p>
@@ -7306,7 +7388,7 @@
               </a:defRPr>
             </a:pPr>
             <a:r>
-              <a:t>能够重复验证</a:t>
+              <a:t>旧结果不能继续使用</a:t>
             </a:r>
           </a:p>
         </p:txBody>
@@ -7345,7 +7427,7 @@
               </a:defRPr>
             </a:pPr>
             <a:r>
-              <a:t>固定种子、预期结果与独立演示库。</a:t>
+              <a:t>失败处理进入统一请求与页面状态，不由临时替代数据掩盖。</a:t>
             </a:r>
           </a:p>
         </p:txBody>
@@ -7427,7 +7509,7 @@
               </a:defRPr>
             </a:pPr>
             <a:r>
-              <a:t>场景覆盖滞销、临期、采购过量和门店缺货</a:t>
+              <a:t>no_data：清晰空状态；needs_input：补充缺项</a:t>
             </a:r>
           </a:p>
         </p:txBody>
@@ -7509,7 +7591,7 @@
               </a:defRPr>
             </a:pPr>
             <a:r>
-              <a:t>缺字段、零销量与库存冲突有明确预期</a:t>
+              <a:t>partial：已有结果与告警同时保留</a:t>
             </a:r>
           </a:p>
         </p:txBody>
@@ -7591,7 +7673,7 @@
               </a:defRPr>
             </a:pPr>
             <a:r>
-              <a:t>测试检查工具结果、输入失效和错误恢复</a:t>
+              <a:t>超时、网络和非法响应明确报错</a:t>
             </a:r>
           </a:p>
         </p:txBody>
@@ -7673,7 +7755,7 @@
               </a:defRPr>
             </a:pPr>
             <a:r>
-              <a:t>独立演示库只承载合成数据与演示记录</a:t>
+              <a:t>快速切换时，旧响应不覆盖当前输入</a:t>
             </a:r>
           </a:p>
         </p:txBody>
@@ -7755,7 +7837,7 @@
               </a:defRPr>
             </a:pPr>
             <a:r>
-              <a:t>通过数量与证据以本次运行报告为准</a:t>
+              <a:t>取消等待不等于撤销服务端运行</a:t>
             </a:r>
           </a:p>
         </p:txBody>
@@ -7837,7 +7919,7 @@
               </a:defRPr>
             </a:pPr>
             <a:r>
-              <a:t>场景文件与后端内置快照分开标注，生成文件不自动导入</a:t>
+              <a:t>夹具中的 AI_TIMEOUT 等是故障注入，不证明真实模型已完成故障测试</a:t>
             </a:r>
           </a:p>
         </p:txBody>
@@ -7941,7 +8023,7 @@
               </a:defRPr>
             </a:pPr>
             <a:r>
-              <a:t>06 / OWNERSHIP</a:t>
+              <a:t>06 / REPRODUCIBILITY</a:t>
             </a:r>
           </a:p>
         </p:txBody>
@@ -7980,7 +8062,7 @@
               </a:defRPr>
             </a:pPr>
             <a:r>
-              <a:t>前端负责清楚呈现</a:t>
+              <a:t>输入可复现</a:t>
             </a:r>
           </a:p>
           <a:p>
@@ -7996,7 +8078,7 @@
               </a:defRPr>
             </a:pPr>
             <a:r>
-              <a:t>后端负责业务计算</a:t>
+              <a:t>验证边界可说明</a:t>
             </a:r>
           </a:p>
         </p:txBody>
@@ -8035,7 +8117,7 @@
               </a:defRPr>
             </a:pPr>
             <a:r>
-              <a:t>浏览器 → 同源 API → 领域工具 → 事实与方案版本。</a:t>
+              <a:t>snack-demo-v1 · snack-policy-v1 · 固定种子与文件校验值。</a:t>
             </a:r>
           </a:p>
         </p:txBody>
@@ -8117,7 +8199,7 @@
               </a:defRPr>
             </a:pPr>
             <a:r>
-              <a:t>朱：五入口、表单、状态、确认、合成场景、测试和演示</a:t>
+              <a:t>七类共享模型提供 CSV 与完整 JSON 输入包</a:t>
             </a:r>
           </a:p>
         </p:txBody>
@@ -8199,7 +8281,7 @@
               </a:defRPr>
             </a:pPr>
             <a:r>
-              <a:t>魏：模型适配、业务工具、数据库、事务与正式契约</a:t>
+              <a:t>参考场景和预期独立保存，不注入在线结果</a:t>
             </a:r>
           </a:p>
         </p:txBody>
@@ -8281,7 +8363,7 @@
               </a:defRPr>
             </a:pPr>
             <a:r>
-              <a:t>接口变化先写契约，再调整消费者</a:t>
+              <a:t>公开静态资源白名单与两个 POST 透明转发</a:t>
             </a:r>
           </a:p>
         </p:txBody>
@@ -8363,7 +8445,7 @@
               </a:defRPr>
             </a:pPr>
             <a:r>
-              <a:t>zmj 分支完成朱的开发；双方在集成分支验收</a:t>
+              <a:t>浏览器夹具验证界面，传输夹具验证代理</a:t>
             </a:r>
           </a:p>
         </p:txBody>
@@ -8371,6 +8453,88 @@
       <p:sp>
         <p:nvSpPr>
           <p:cNvPr id="13" name="Rectangle 12"/>
+          <p:cNvSpPr/>
+          <p:nvPr/>
+        </p:nvSpPr>
+        <p:spPr>
+          <a:xfrm>
+            <a:off x="640080" y="4956048"/>
+            <a:ext cx="41148" cy="41148"/>
+          </a:xfrm>
+          <a:prstGeom prst="rect">
+            <a:avLst/>
+          </a:prstGeom>
+          <a:solidFill>
+            <a:srgbClr val="9AD7B7"/>
+          </a:solidFill>
+          <a:ln>
+            <a:noFill/>
+          </a:ln>
+        </p:spPr>
+        <p:style>
+          <a:lnRef idx="1">
+            <a:schemeClr val="accent1"/>
+          </a:lnRef>
+          <a:fillRef idx="3">
+            <a:schemeClr val="accent1"/>
+          </a:fillRef>
+          <a:effectRef idx="2">
+            <a:schemeClr val="accent1"/>
+          </a:effectRef>
+          <a:fontRef idx="minor">
+            <a:schemeClr val="lt1"/>
+          </a:fontRef>
+        </p:style>
+        <p:txBody>
+          <a:bodyPr rtlCol="0" anchor="ctr"/>
+          <a:lstStyle/>
+          <a:p>
+            <a:pPr algn="ctr"/>
+          </a:p>
+        </p:txBody>
+      </p:sp>
+      <p:sp>
+        <p:nvSpPr>
+          <p:cNvPr id="14" name="TextBox 13"/>
+          <p:cNvSpPr txBox="1"/>
+          <p:nvPr/>
+        </p:nvSpPr>
+        <p:spPr>
+          <a:xfrm>
+            <a:off x="822960" y="4837176"/>
+            <a:ext cx="10607040" cy="393192"/>
+          </a:xfrm>
+          <a:prstGeom prst="rect">
+            <a:avLst/>
+          </a:prstGeom>
+          <a:noFill/>
+        </p:spPr>
+        <p:txBody>
+          <a:bodyPr wrap="square" lIns="0" rIns="0" tIns="0" bIns="0">
+            <a:spAutoFit/>
+          </a:bodyPr>
+          <a:lstStyle/>
+          <a:p>
+            <a:pPr>
+              <a:spcAft>
+                <a:spcPts val="500"/>
+              </a:spcAft>
+              <a:defRPr sz="1800" b="0">
+                <a:solidFill>
+                  <a:srgbClr val="EEF3F6"/>
+                </a:solidFill>
+                <a:latin typeface="Microsoft YaHei"/>
+              </a:defRPr>
+            </a:pPr>
+            <a:r>
+              <a:t>实测 Node 52 项、Python 前端相关 46 项通过</a:t>
+            </a:r>
+          </a:p>
+        </p:txBody>
+      </p:sp>
+      <p:sp>
+        <p:nvSpPr>
+          <p:cNvPr id="15" name="Rectangle 14"/>
           <p:cNvSpPr/>
           <p:nvPr/>
         </p:nvSpPr>
@@ -8413,7 +8577,7 @@
       </p:sp>
       <p:sp>
         <p:nvSpPr>
-          <p:cNvPr id="14" name="TextBox 13"/>
+          <p:cNvPr id="16" name="TextBox 15"/>
           <p:cNvSpPr txBox="1"/>
           <p:nvPr/>
         </p:nvSpPr>
@@ -8445,14 +8609,14 @@
               </a:defRPr>
             </a:pPr>
             <a:r>
-              <a:t>沿用模块化单体，不在前端复制业务算法</a:t>
-            </a:r>
-          </a:p>
-        </p:txBody>
-      </p:sp>
-      <p:sp>
-        <p:nvSpPr>
-          <p:cNvPr id="15" name="TextBox 14"/>
+              <a:t>另有 39 项旧后端回归；夹具验证不证明真实 v0.3 后端通过</a:t>
+            </a:r>
+          </a:p>
+        </p:txBody>
+      </p:sp>
+      <p:sp>
+        <p:nvSpPr>
+          <p:cNvPr id="17" name="TextBox 16"/>
           <p:cNvSpPr txBox="1"/>
           <p:nvPr/>
         </p:nvSpPr>
@@ -8549,7 +8713,7 @@
               </a:defRPr>
             </a:pPr>
             <a:r>
-              <a:t>07 / NEXT</a:t>
+              <a:t>07 / INTEGRATION</a:t>
             </a:r>
           </a:p>
         </p:txBody>
@@ -8588,7 +8752,7 @@
               </a:defRPr>
             </a:pPr>
             <a:r>
-              <a:t>今天能演示的</a:t>
+              <a:t>下一步</a:t>
             </a:r>
           </a:p>
           <a:p>
@@ -8604,7 +8768,7 @@
               </a:defRPr>
             </a:pPr>
             <a:r>
-              <a:t>与下一步要完成的</a:t>
+              <a:t>接入魏的真实 v0.3 服务</a:t>
             </a:r>
           </a:p>
         </p:txBody>
@@ -8643,7 +8807,7 @@
               </a:defRPr>
             </a:pPr>
             <a:r>
-              <a:t>先交付可信的流程，再接入真实智能与真实执行。</a:t>
+              <a:t>先跑通滞销样例，再验证五个 Agent、会话模拟和错误恢复。</a:t>
             </a:r>
           </a:p>
         </p:txBody>
@@ -8725,7 +8889,7 @@
               </a:defRPr>
             </a:pPr>
             <a:r>
-              <a:t>本次：合成场景、五入口、规则测算、人工审批、执行草稿</a:t>
+              <a:t>实现两条路由并加载约定的数据与规则版本</a:t>
             </a:r>
           </a:p>
         </p:txBody>
@@ -8807,7 +8971,7 @@
               </a:defRPr>
             </a:pPr>
             <a:r>
-              <a:t>模型：真实请求、结构校验、证据引用与失败恢复</a:t>
+              <a:t>确认库存资金时点与日内到货顺序</a:t>
             </a:r>
           </a:p>
         </p:txBody>
@@ -8889,7 +9053,7 @@
               </a:defRPr>
             </a:pPr>
             <a:r>
-              <a:t>后端：重置保护、资源隔离、事务、版本冲突和权限</a:t>
+              <a:t>确认效期预测日期和 FEFO 分配</a:t>
             </a:r>
           </a:p>
         </p:txBody>
@@ -8971,7 +9135,7 @@
               </a:defRPr>
             </a:pPr>
             <a:r>
-              <a:t>集成：ERP 数据与执行回执、财务结果核验</a:t>
+              <a:t>确认采购箱规与后续补货假设</a:t>
             </a:r>
           </a:p>
         </p:txBody>
@@ -8979,6 +9143,88 @@
       <p:sp>
         <p:nvSpPr>
           <p:cNvPr id="13" name="Rectangle 12"/>
+          <p:cNvSpPr/>
+          <p:nvPr/>
+        </p:nvSpPr>
+        <p:spPr>
+          <a:xfrm>
+            <a:off x="640080" y="4956048"/>
+            <a:ext cx="41148" cy="41148"/>
+          </a:xfrm>
+          <a:prstGeom prst="rect">
+            <a:avLst/>
+          </a:prstGeom>
+          <a:solidFill>
+            <a:srgbClr val="9AD7B7"/>
+          </a:solidFill>
+          <a:ln>
+            <a:noFill/>
+          </a:ln>
+        </p:spPr>
+        <p:style>
+          <a:lnRef idx="1">
+            <a:schemeClr val="accent1"/>
+          </a:lnRef>
+          <a:fillRef idx="3">
+            <a:schemeClr val="accent1"/>
+          </a:fillRef>
+          <a:effectRef idx="2">
+            <a:schemeClr val="accent1"/>
+          </a:effectRef>
+          <a:fontRef idx="minor">
+            <a:schemeClr val="lt1"/>
+          </a:fontRef>
+        </p:style>
+        <p:txBody>
+          <a:bodyPr rtlCol="0" anchor="ctr"/>
+          <a:lstStyle/>
+          <a:p>
+            <a:pPr algn="ctr"/>
+          </a:p>
+        </p:txBody>
+      </p:sp>
+      <p:sp>
+        <p:nvSpPr>
+          <p:cNvPr id="14" name="TextBox 13"/>
+          <p:cNvSpPr txBox="1"/>
+          <p:nvPr/>
+        </p:nvSpPr>
+        <p:spPr>
+          <a:xfrm>
+            <a:off x="822960" y="4837176"/>
+            <a:ext cx="10607040" cy="393192"/>
+          </a:xfrm>
+          <a:prstGeom prst="rect">
+            <a:avLst/>
+          </a:prstGeom>
+          <a:noFill/>
+        </p:spPr>
+        <p:txBody>
+          <a:bodyPr wrap="square" lIns="0" rIns="0" tIns="0" bIns="0">
+            <a:spAutoFit/>
+          </a:bodyPr>
+          <a:lstStyle/>
+          <a:p>
+            <a:pPr>
+              <a:spcAft>
+                <a:spcPts val="500"/>
+              </a:spcAft>
+              <a:defRPr sz="1800" b="0">
+                <a:solidFill>
+                  <a:srgbClr val="EEF3F6"/>
+                </a:solidFill>
+                <a:latin typeface="Microsoft YaHei"/>
+              </a:defRPr>
+            </a:pPr>
+            <a:r>
+              <a:t>实测模型、工具、证据、并发与模拟决策</a:t>
+            </a:r>
+          </a:p>
+        </p:txBody>
+      </p:sp>
+      <p:sp>
+        <p:nvSpPr>
+          <p:cNvPr id="15" name="Rectangle 14"/>
           <p:cNvSpPr/>
           <p:nvPr/>
         </p:nvSpPr>
@@ -9021,7 +9267,7 @@
       </p:sp>
       <p:sp>
         <p:nvSpPr>
-          <p:cNvPr id="14" name="TextBox 13"/>
+          <p:cNvPr id="16" name="TextBox 15"/>
           <p:cNvSpPr txBox="1"/>
           <p:nvPr/>
         </p:nvSpPr>
@@ -9053,14 +9299,14 @@
               </a:defRPr>
             </a:pPr>
             <a:r>
-              <a:t>GitHub / lyu054553-sketch/xihhhhh · 分支 zmj</a:t>
-            </a:r>
-          </a:p>
-        </p:txBody>
-      </p:sp>
-      <p:sp>
-        <p:nvSpPr>
-          <p:cNvPr id="15" name="TextBox 14"/>
+              <a:t>GitHub / lyu054553-sketch/xihhhhh · 朱的开发分支 zmj</a:t>
+            </a:r>
+          </a:p>
+        </p:txBody>
+      </p:sp>
+      <p:sp>
+        <p:nvSpPr>
+          <p:cNvPr id="17" name="TextBox 16"/>
           <p:cNvSpPr txBox="1"/>
           <p:nvPr/>
         </p:nvSpPr>

</xml_diff>

<commit_message>
docs: verify integrated concurrency fix and refresh demo evidence
</commit_message>
<xml_diff>
--- a/docs/DEMO_SLIDES.pptx
+++ b/docs/DEMO_SLIDES.pptx
@@ -929,7 +929,7 @@
           <a:lstStyle/>
           <a:p>
             <a:r>
-              <a:t>本轮浏览器主流程使用实际后端，没有用固定响应替代计算。独立临时数据库在没有写入和重置的情况下，并发读取仍出现500，需要魏修复数据访问层后复验。录像记录一次成功流程，不能代替全量验收，也不证明模型理解、客户收益或 ERP 执行。</a:t>
+              <a:t>本轮已合入魏 lanyangyang 的19794ca（并发修复3cc6c4a）。2026-10-03本地统一验收六步全部通过，Python测试包含33项实际后端浏览器用例；独立45次串行和9线程150次并发读取均为200，内容与串行基准一致。没有用固定响应替代计算，没有跳过失败用例。远端CI尚待验证，原联调录像本轮未重录；这些结果不证明模型理解、客户收益、跨进程事务或 ERP 执行。</a:t>
             </a:r>
           </a:p>
         </p:txBody>
@@ -6293,7 +6293,7 @@
               </a:defRPr>
             </a:pPr>
             <a:r>
-              <a:t>幂等键帮助防重复；服务端 expected_version 并发校验仍待完善</a:t>
+              <a:t>幂等键帮助防重复；服务端 expected_version 原子校验仍待完善</a:t>
             </a:r>
           </a:p>
         </p:txBody>
@@ -7509,7 +7509,7 @@
               </a:defRPr>
             </a:pPr>
             <a:r>
-              <a:t>24 条语言参考尚未运行模型评估</a:t>
+              <a:t>两组各24条人工参考尚未运行模型评估</a:t>
             </a:r>
           </a:p>
         </p:txBody>
@@ -8199,7 +8199,7 @@
               </a:defRPr>
             </a:pPr>
             <a:r>
-              <a:t>已复现并发读取 500，完整联调未通过；详见验证记录</a:t>
+              <a:t>本地复验：JS 112/112 · Python 153/153 · 并发读取 150/150</a:t>
             </a:r>
           </a:p>
         </p:txBody>
@@ -8479,7 +8479,7 @@
               </a:defRPr>
             </a:pPr>
             <a:r>
-              <a:t>完善服务端版本失效、并发与权限</a:t>
+              <a:t>完善跨进程事务、版本失效与权限</a:t>
             </a:r>
           </a:p>
         </p:txBody>

</xml_diff>

<commit_message>
docs: record task follow-up validation and next Zhu Wei milestones
</commit_message>
<xml_diff>
--- a/docs/DEMO_SLIDES.pptx
+++ b/docs/DEMO_SLIDES.pptx
@@ -719,7 +719,7 @@
           <a:lstStyle/>
           <a:p>
             <a:r>
-              <a:t>审批成功不表示已经调出库存。execute 只创建 draft_pending_external_execution。即使人工登记完成，也不能声称外部操作由系统自动完成。并发版本检查仍是待魏完善的服务端事项。</a:t>
+              <a:t>审批成功不表示已经调出库存。execute 只创建 draft_pending_external_execution。今日待办可以按门店、商品和编号定位；任务显示对应保存版本的业务身份。未保存人工回执可跨分类和页面继续填写，保存前读取最新状态，关联一致才清除编辑。即使人工登记完成，也不能声称外部操作由系统自动完成。读取与写入之间的原子版本检查仍由魏完善。</a:t>
             </a:r>
           </a:p>
         </p:txBody>
@@ -929,7 +929,7 @@
           <a:lstStyle/>
           <a:p>
             <a:r>
-              <a:t>本轮已合入魏 lanyangyang 的19794ca（并发修复3cc6c4a）。2026-10-03本地统一验收六步全部通过，Python测试包含33项实际后端浏览器用例；独立45次串行和9线程150次并发读取均为200，内容与串行基准一致。没有用固定响应替代计算，没有跳过失败用例。远端CI尚待验证，原联调录像本轮未重录；这些结果不证明模型理解、客户收益、跨进程事务或 ERP 执行。</a:t>
+              <a:t>后端仍为魏 lanyangyang 的19794ca（并发修复3cc6c4a）。2026-10-03本地统一验收六步全部通过，Python测试包含43项实际后端浏览器用例；独立45次串行和9线程150次并发读取均为200，内容与串行基准一致。没有用固定响应替代计算，没有跳过失败用例。Windows与Ubuntu使用相同验收入口，远端结果以Actions对应提交为准；仓库中的旧联调录像未替换，本轮证据保存在验收目录。这些结果不证明模型理解、客户收益、跨进程事务或ERP执行。</a:t>
             </a:r>
           </a:p>
         </p:txBody>
@@ -6211,7 +6211,7 @@
               </a:defRPr>
             </a:pPr>
             <a:r>
-              <a:t>人工回执说明来源，不能伪装自动执行</a:t>
+              <a:t>回执按任务保留，服务记录变化先核对</a:t>
             </a:r>
           </a:p>
         </p:txBody>
@@ -8199,7 +8199,7 @@
               </a:defRPr>
             </a:pPr>
             <a:r>
-              <a:t>本地复验：JS 112/112 · Python 153/153 · 并发读取 150/150</a:t>
+              <a:t>本地复验：JS 138/138 · Python 163/163 · 并发读取 150/150</a:t>
             </a:r>
           </a:p>
         </p:txBody>

</xml_diff>